<commit_message>
Rebuild S5 slide: crop diagram, add a real stat callout
The prior S5 slide crammed the full annotated PDF page (diagram plus
a dense CP/D reference panel) into a small box, illegible at slide
scale. Crop a diagram-only image from the same source, place it large
on the left, and replace the small paragraph on the right with an
actual stat callout ($44 hero number, supporting stats, one sentence
of context) using the template's own brand colors. Validated with
scripts/office/validate.py and visually confirmed by rendering through
LibreOffice (now installed locally) rather than guessing at layout.

Co-Authored-By: Claude Sonnet 5 <noreply@anthropic.com>
</commit_message>
<xml_diff>
--- a/project/Board-Presentation-Sweetgreen.pptx
+++ b/project/Board-Presentation-Sweetgreen.pptx
@@ -11071,48 +11071,9 @@
           </a:p>
         </p:txBody>
       </p:sp>
-      <p:sp>
-        <p:nvSpPr>
-          <p:cNvPr id="14" name="Text 12"/>
-          <p:cNvSpPr/>
-          <p:nvPr/>
-        </p:nvSpPr>
-        <p:spPr>
-          <a:xfrm>
-            <a:off x="457200" y="2286000"/>
-            <a:ext cx="7772400" cy="700000"/>
-          </a:xfrm>
-          <a:prstGeom prst="rect">
-            <a:avLst/>
-          </a:prstGeom>
-          <a:noFill/>
-          <a:ln/>
-        </p:spPr>
-        <p:txBody>
-          <a:bodyPr wrap="square" rtlCol="0" anchor="t"/>
-          <a:lstStyle/>
-          <a:p>
-            <a:pPr algn="l" marL="228600" indent="-228600">
-              <a:lnSpc>
-                <a:spcPct val="105000"/>
-              </a:lnSpc>
-              <a:spcAft>
-                <a:spcPts val="800"/>
-              </a:spcAft>
-              <a:buSzPct val="100000"/>
-              <a:buChar char="•"/>
-            </a:pPr>
-            <a:r>
-              <a:rPr sz="1400"/>
-              <a:t>$44 in modeled exposure across 6 of 30 synthetic orders (20% rework rate), averaging 18.7 minutes late: live vs. nightly-cached availability data disagree at the kitchen feasibility check, the exact seam where digital ordering meets kitchen execution.</a:t>
-            </a:r>
-            <a:endParaRPr lang="en-US" sz="1600" dirty="0"/>
-          </a:p>
-        </p:txBody>
-      </p:sp>
       <p:pic>
         <p:nvPicPr>
-          <p:cNvPr id="15" name="Picture 14" descr="Order-and-Payment-Process-Map-Annotated.png"/>
+          <p:cNvPr id="14" name="Picture 13" descr="Order-and-Payment-Process-Map-Diagram-Only.png"/>
           <p:cNvPicPr>
             <a:picLocks noChangeAspect="1"/>
           </p:cNvPicPr>
@@ -11126,14 +11087,150 @@
         </p:blipFill>
         <p:spPr>
           <a:xfrm>
-            <a:off x="2753095" y="3040000"/>
-            <a:ext cx="3180609" cy="3240000"/>
+            <a:off x="457200" y="2286000"/>
+            <a:ext cx="1963051" cy="4014000"/>
           </a:xfrm>
           <a:prstGeom prst="rect">
             <a:avLst/>
           </a:prstGeom>
         </p:spPr>
       </p:pic>
+      <p:sp>
+        <p:nvSpPr>
+          <p:cNvPr id="15" name="TextBox 14"/>
+          <p:cNvSpPr txBox="1"/>
+          <p:nvPr/>
+        </p:nvSpPr>
+        <p:spPr>
+          <a:xfrm>
+            <a:off x="2740251" y="2386000"/>
+            <a:ext cx="5509389" cy="1350000"/>
+          </a:xfrm>
+          <a:prstGeom prst="rect">
+            <a:avLst/>
+          </a:prstGeom>
+          <a:noFill/>
+        </p:spPr>
+        <p:txBody>
+          <a:bodyPr wrap="square" lIns="0" rIns="0" tIns="0" bIns="0">
+            <a:spAutoFit/>
+          </a:bodyPr>
+          <a:lstStyle/>
+          <a:p>
+            <a:r>
+              <a:rPr sz="8000" b="1" i="0">
+                <a:solidFill>
+                  <a:srgbClr val="57068C"/>
+                </a:solidFill>
+                <a:latin typeface="Cambria"/>
+              </a:rPr>
+              <a:t>$44</a:t>
+            </a:r>
+          </a:p>
+        </p:txBody>
+      </p:sp>
+      <p:sp>
+        <p:nvSpPr>
+          <p:cNvPr id="16" name="TextBox 15"/>
+          <p:cNvSpPr txBox="1"/>
+          <p:nvPr/>
+        </p:nvSpPr>
+        <p:spPr>
+          <a:xfrm>
+            <a:off x="2740251" y="3756000"/>
+            <a:ext cx="5509389" cy="380000"/>
+          </a:xfrm>
+          <a:prstGeom prst="rect">
+            <a:avLst/>
+          </a:prstGeom>
+          <a:noFill/>
+        </p:spPr>
+        <p:txBody>
+          <a:bodyPr wrap="square" lIns="0" rIns="0" tIns="0" bIns="0">
+            <a:spAutoFit/>
+          </a:bodyPr>
+          <a:lstStyle/>
+          <a:p>
+            <a:r>
+              <a:rPr sz="1800" b="0" i="1">
+                <a:solidFill>
+                  <a:srgbClr val="666666"/>
+                </a:solidFill>
+                <a:latin typeface="Calibri"/>
+              </a:rPr>
+              <a:t>in modeled exposure</a:t>
+            </a:r>
+          </a:p>
+        </p:txBody>
+      </p:sp>
+      <p:sp>
+        <p:nvSpPr>
+          <p:cNvPr id="17" name="TextBox 16"/>
+          <p:cNvSpPr txBox="1"/>
+          <p:nvPr/>
+        </p:nvSpPr>
+        <p:spPr>
+          <a:xfrm>
+            <a:off x="2740251" y="4356000"/>
+            <a:ext cx="5509389" cy="700000"/>
+          </a:xfrm>
+          <a:prstGeom prst="rect">
+            <a:avLst/>
+          </a:prstGeom>
+          <a:noFill/>
+        </p:spPr>
+        <p:txBody>
+          <a:bodyPr wrap="square" lIns="0" rIns="0" tIns="0" bIns="0">
+            <a:spAutoFit/>
+          </a:bodyPr>
+          <a:lstStyle/>
+          <a:p>
+            <a:r>
+              <a:rPr sz="1600" b="1" i="0">
+                <a:solidFill>
+                  <a:srgbClr val="333333"/>
+                </a:solidFill>
+                <a:latin typeface="Calibri"/>
+              </a:rPr>
+              <a:t>6 of 30 synthetic orders  ·  20% rework rate  ·  18.7 min average lateness</a:t>
+            </a:r>
+          </a:p>
+        </p:txBody>
+      </p:sp>
+      <p:sp>
+        <p:nvSpPr>
+          <p:cNvPr id="18" name="TextBox 17"/>
+          <p:cNvSpPr txBox="1"/>
+          <p:nvPr/>
+        </p:nvSpPr>
+        <p:spPr>
+          <a:xfrm>
+            <a:off x="2740251" y="5256000"/>
+            <a:ext cx="5509389" cy="900000"/>
+          </a:xfrm>
+          <a:prstGeom prst="rect">
+            <a:avLst/>
+          </a:prstGeom>
+          <a:noFill/>
+        </p:spPr>
+        <p:txBody>
+          <a:bodyPr wrap="square" lIns="0" rIns="0" tIns="0" bIns="0">
+            <a:spAutoFit/>
+          </a:bodyPr>
+          <a:lstStyle/>
+          <a:p>
+            <a:r>
+              <a:rPr sz="1500" b="0" i="0">
+                <a:solidFill>
+                  <a:srgbClr val="333333"/>
+                </a:solidFill>
+                <a:latin typeface="Calibri"/>
+              </a:rPr>
+              <a:t>Live vs. nightly-cached availability data disagree at the kitchen feasibility check (②), the exact seam where digital ordering meets kitchen execution.</a:t>
+            </a:r>
+          </a:p>
+        </p:txBody>
+      </p:sp>
     </p:spTree>
   </p:cSld>
   <p:clrMapOvr>

</xml_diff>